<commit_message>
a0 revision v2.1: clarify 'one surface two hosts', fix zh image paths, drop series roadmap
- zh article moved next to the en one (<slug>.zh.md) so both use the same
  relative image paths; ../images broke rendering in previewers
- explain 'One HTTP Surface, Two Hosts' in both articles: surface = the two
  routes your code implements, hosts = local Uvicorn vs managed microVM;
  agentcore invoke is a client, not a third interface; F5 figure shows the
  hosted /invocations URL
- articles now end at takeaways: removed the series-roadmap section (en/zh)
  and the roadmap slide (deck 23 -> 22); F7 figure deleted (8 -> 7 figures)
- PLAN.md: zh-path convention, structure table, figure spec updated
</commit_message>
<xml_diff>
--- a/articles/decks/aws-agentcore-under-the-hood.pptx
+++ b/articles/decks/aws-agentcore-under-the-hood.pptx
@@ -27,7 +27,6 @@
     <p:sldId id="275" r:id="rId26"/>
     <p:sldId id="276" r:id="rId27"/>
     <p:sldId id="277" r:id="rId28"/>
-    <p:sldId id="278" r:id="rId29"/>
   </p:sldIdLst>
   <p:sldSz cx="12191695" cy="6858000" type="screen4x3"/>
   <p:notesSz cx="6858000" cy="9144000"/>
@@ -3358,7 +3357,7 @@
               </a:defRPr>
             </a:pPr>
             <a:r>
-              <a:t>AgentCore Series · Article 0 of 8 · measured on a real deployment in us-east-1</a:t>
+              <a:t>AgentCore in Action · measured on a real deployment in us-east-1</a:t>
             </a:r>
           </a:p>
         </p:txBody>
@@ -7117,8 +7116,8 @@
         </p:blipFill>
         <p:spPr>
           <a:xfrm>
-            <a:off x="3429000" y="1965960"/>
-            <a:ext cx="5852160" cy="4116832"/>
+            <a:off x="3401568" y="1874519"/>
+            <a:ext cx="5394960" cy="3937572"/>
           </a:xfrm>
           <a:prstGeom prst="rect">
             <a:avLst/>
@@ -7127,7 +7126,46 @@
       </p:pic>
       <p:sp>
         <p:nvSpPr>
-          <p:cNvPr id="8" name="Rectangle 7"/>
+          <p:cNvPr id="8" name="TextBox 7"/>
+          <p:cNvSpPr txBox="1"/>
+          <p:nvPr/>
+        </p:nvSpPr>
+        <p:spPr>
+          <a:xfrm>
+            <a:off x="548640" y="5943600"/>
+            <a:ext cx="11064240" cy="411480"/>
+          </a:xfrm>
+          <a:prstGeom prst="rect">
+            <a:avLst/>
+          </a:prstGeom>
+          <a:noFill/>
+        </p:spPr>
+        <p:txBody>
+          <a:bodyPr wrap="square" anchor="t">
+            <a:spAutoFit/>
+          </a:bodyPr>
+          <a:lstStyle/>
+          <a:p>
+            <a:pPr algn="ctr">
+              <a:lnSpc>
+                <a:spcPct val="100000"/>
+              </a:lnSpc>
+              <a:defRPr sz="1300" b="0" i="0">
+                <a:solidFill>
+                  <a:srgbClr val="64748B"/>
+                </a:solidFill>
+                <a:latin typeface="Helvetica Neue"/>
+              </a:defRPr>
+            </a:pPr>
+            <a:r>
+              <a:t>agentcore invoke = a CLI client for the hosted /invocations endpoint, not a third interface.</a:t>
+            </a:r>
+          </a:p>
+        </p:txBody>
+      </p:sp>
+      <p:sp>
+        <p:nvSpPr>
+          <p:cNvPr id="9" name="Rectangle 8"/>
           <p:cNvSpPr/>
           <p:nvPr/>
         </p:nvSpPr>
@@ -7171,7 +7209,7 @@
       </p:sp>
       <p:sp>
         <p:nvSpPr>
-          <p:cNvPr id="9" name="TextBox 8"/>
+          <p:cNvPr id="10" name="TextBox 9"/>
           <p:cNvSpPr txBox="1"/>
           <p:nvPr/>
         </p:nvSpPr>
@@ -7210,7 +7248,7 @@
       </p:sp>
       <p:sp>
         <p:nvSpPr>
-          <p:cNvPr id="10" name="TextBox 9"/>
+          <p:cNvPr id="11" name="TextBox 10"/>
           <p:cNvSpPr txBox="1"/>
           <p:nvPr/>
         </p:nvSpPr>
@@ -13071,364 +13109,6 @@
   <p:cSld>
     <p:bg>
       <p:bgPr>
-        <a:solidFill>
-          <a:srgbClr val="FFFFFF"/>
-        </a:solidFill>
-        <a:effectLst/>
-      </p:bgPr>
-    </p:bg>
-    <p:spTree>
-      <p:nvGrpSpPr>
-        <p:cNvPr id="1" name=""/>
-        <p:cNvGrpSpPr/>
-        <p:nvPr/>
-      </p:nvGrpSpPr>
-      <p:grpSpPr/>
-      <p:sp>
-        <p:nvSpPr>
-          <p:cNvPr id="2" name="Rounded Rectangle 1"/>
-          <p:cNvSpPr/>
-          <p:nvPr/>
-        </p:nvSpPr>
-        <p:spPr>
-          <a:xfrm>
-            <a:off x="548640" y="384048"/>
-            <a:ext cx="1371600" cy="310896"/>
-          </a:xfrm>
-          <a:prstGeom prst="roundRect">
-            <a:avLst>
-              <a:gd name="adj" fmla="val 50000"/>
-            </a:avLst>
-          </a:prstGeom>
-          <a:solidFill>
-            <a:srgbClr val="EA580C"/>
-          </a:solidFill>
-          <a:ln>
-            <a:noFill/>
-          </a:ln>
-          <a:effectLst/>
-        </p:spPr>
-        <p:style>
-          <a:lnRef idx="1">
-            <a:schemeClr val="accent1"/>
-          </a:lnRef>
-          <a:fillRef idx="3">
-            <a:schemeClr val="accent1"/>
-          </a:fillRef>
-          <a:effectRef idx="2">
-            <a:schemeClr val="accent1"/>
-          </a:effectRef>
-          <a:fontRef idx="minor">
-            <a:schemeClr val="lt1"/>
-          </a:fontRef>
-        </p:style>
-        <p:txBody>
-          <a:bodyPr rtlCol="0" anchor="ctr" wrap="none"/>
-          <a:lstStyle/>
-          <a:p>
-            <a:pPr algn="ctr">
-              <a:defRPr sz="1100" b="1">
-                <a:solidFill>
-                  <a:srgbClr val="FFFFFF"/>
-                </a:solidFill>
-                <a:latin typeface="Helvetica Neue"/>
-              </a:defRPr>
-            </a:pPr>
-            <a:r>
-              <a:t>THE SERIES</a:t>
-            </a:r>
-          </a:p>
-        </p:txBody>
-      </p:sp>
-      <p:sp>
-        <p:nvSpPr>
-          <p:cNvPr id="3" name="TextBox 2"/>
-          <p:cNvSpPr txBox="1"/>
-          <p:nvPr/>
-        </p:nvSpPr>
-        <p:spPr>
-          <a:xfrm>
-            <a:off x="548640" y="786384"/>
-            <a:ext cx="11064240" cy="777240"/>
-          </a:xfrm>
-          <a:prstGeom prst="rect">
-            <a:avLst/>
-          </a:prstGeom>
-          <a:noFill/>
-        </p:spPr>
-        <p:txBody>
-          <a:bodyPr wrap="square" anchor="t">
-            <a:spAutoFit/>
-          </a:bodyPr>
-          <a:lstStyle/>
-          <a:p>
-            <a:pPr algn="l">
-              <a:lnSpc>
-                <a:spcPct val="100000"/>
-              </a:lnSpc>
-              <a:defRPr sz="3000" b="1" i="0">
-                <a:solidFill>
-                  <a:srgbClr val="0F172A"/>
-                </a:solidFill>
-                <a:latin typeface="Helvetica Neue"/>
-              </a:defRPr>
-            </a:pPr>
-            <a:r>
-              <a:t>Next: 7 use cases, rising difficulty, one pattern</a:t>
-            </a:r>
-          </a:p>
-        </p:txBody>
-      </p:sp>
-      <p:sp>
-        <p:nvSpPr>
-          <p:cNvPr id="4" name="Rectangle 3"/>
-          <p:cNvSpPr/>
-          <p:nvPr/>
-        </p:nvSpPr>
-        <p:spPr>
-          <a:xfrm>
-            <a:off x="566928" y="1481328"/>
-            <a:ext cx="1371600" cy="68580"/>
-          </a:xfrm>
-          <a:prstGeom prst="rect">
-            <a:avLst/>
-          </a:prstGeom>
-          <a:gradFill rotWithShape="1">
-            <a:gsLst>
-              <a:gs pos="0">
-                <a:srgbClr val="EA580C"/>
-              </a:gs>
-              <a:gs pos="100000">
-                <a:srgbClr val="F3A379"/>
-              </a:gs>
-            </a:gsLst>
-            <a:lin scaled="0" ang="0"/>
-          </a:gradFill>
-          <a:ln>
-            <a:noFill/>
-          </a:ln>
-          <a:effectLst/>
-        </p:spPr>
-        <p:style>
-          <a:lnRef idx="1">
-            <a:schemeClr val="accent1"/>
-          </a:lnRef>
-          <a:fillRef idx="3">
-            <a:schemeClr val="accent1"/>
-          </a:fillRef>
-          <a:effectRef idx="2">
-            <a:schemeClr val="accent1"/>
-          </a:effectRef>
-          <a:fontRef idx="minor">
-            <a:schemeClr val="lt1"/>
-          </a:fontRef>
-        </p:style>
-        <p:txBody>
-          <a:bodyPr rtlCol="0" anchor="ctr"/>
-          <a:lstStyle/>
-          <a:p>
-            <a:pPr algn="ctr"/>
-          </a:p>
-        </p:txBody>
-      </p:sp>
-      <p:pic>
-        <p:nvPicPr>
-          <p:cNvPr id="5" name="Picture 4" descr="F7-series-roadmap.png"/>
-          <p:cNvPicPr>
-            <a:picLocks noChangeAspect="1"/>
-          </p:cNvPicPr>
-          <p:nvPr/>
-        </p:nvPicPr>
-        <p:blipFill>
-          <a:blip r:embed="rId2"/>
-          <a:stretch>
-            <a:fillRect/>
-          </a:stretch>
-        </p:blipFill>
-        <p:spPr>
-          <a:xfrm>
-            <a:off x="3063240" y="1874519"/>
-            <a:ext cx="6400800" cy="4049395"/>
-          </a:xfrm>
-          <a:prstGeom prst="rect">
-            <a:avLst/>
-          </a:prstGeom>
-        </p:spPr>
-      </p:pic>
-      <p:sp>
-        <p:nvSpPr>
-          <p:cNvPr id="6" name="TextBox 5"/>
-          <p:cNvSpPr txBox="1"/>
-          <p:nvPr/>
-        </p:nvSpPr>
-        <p:spPr>
-          <a:xfrm>
-            <a:off x="548640" y="5989320"/>
-            <a:ext cx="11064240" cy="411480"/>
-          </a:xfrm>
-          <a:prstGeom prst="rect">
-            <a:avLst/>
-          </a:prstGeom>
-          <a:noFill/>
-        </p:spPr>
-        <p:txBody>
-          <a:bodyPr wrap="square" anchor="t">
-            <a:spAutoFit/>
-          </a:bodyPr>
-          <a:lstStyle/>
-          <a:p>
-            <a:pPr algn="ctr">
-              <a:lnSpc>
-                <a:spcPct val="100000"/>
-              </a:lnSpc>
-              <a:defRPr sz="1300" b="0" i="0">
-                <a:solidFill>
-                  <a:srgbClr val="64748B"/>
-                </a:solidFill>
-                <a:latin typeface="Helvetica Neue"/>
-              </a:defRPr>
-            </a:pPr>
-            <a:r>
-              <a:t>Each use case deploys standalone. Same pattern: real deployment, measured outputs, honest failures.</a:t>
-            </a:r>
-          </a:p>
-        </p:txBody>
-      </p:sp>
-      <p:sp>
-        <p:nvSpPr>
-          <p:cNvPr id="7" name="Rectangle 6"/>
-          <p:cNvSpPr/>
-          <p:nvPr/>
-        </p:nvSpPr>
-        <p:spPr>
-          <a:xfrm>
-            <a:off x="548640" y="6455664"/>
-            <a:ext cx="11091672" cy="10972"/>
-          </a:xfrm>
-          <a:prstGeom prst="rect">
-            <a:avLst/>
-          </a:prstGeom>
-          <a:solidFill>
-            <a:srgbClr val="CBD5E1"/>
-          </a:solidFill>
-          <a:ln>
-            <a:noFill/>
-          </a:ln>
-          <a:effectLst/>
-        </p:spPr>
-        <p:style>
-          <a:lnRef idx="1">
-            <a:schemeClr val="accent1"/>
-          </a:lnRef>
-          <a:fillRef idx="3">
-            <a:schemeClr val="accent1"/>
-          </a:fillRef>
-          <a:effectRef idx="2">
-            <a:schemeClr val="accent1"/>
-          </a:effectRef>
-          <a:fontRef idx="minor">
-            <a:schemeClr val="lt1"/>
-          </a:fontRef>
-        </p:style>
-        <p:txBody>
-          <a:bodyPr rtlCol="0" anchor="ctr"/>
-          <a:lstStyle/>
-          <a:p>
-            <a:pPr algn="ctr"/>
-          </a:p>
-        </p:txBody>
-      </p:sp>
-      <p:sp>
-        <p:nvSpPr>
-          <p:cNvPr id="8" name="TextBox 7"/>
-          <p:cNvSpPr txBox="1"/>
-          <p:nvPr/>
-        </p:nvSpPr>
-        <p:spPr>
-          <a:xfrm>
-            <a:off x="548640" y="6510528"/>
-            <a:ext cx="5486400" cy="274320"/>
-          </a:xfrm>
-          <a:prstGeom prst="rect">
-            <a:avLst/>
-          </a:prstGeom>
-          <a:noFill/>
-        </p:spPr>
-        <p:txBody>
-          <a:bodyPr wrap="square" anchor="t">
-            <a:spAutoFit/>
-          </a:bodyPr>
-          <a:lstStyle/>
-          <a:p>
-            <a:pPr algn="l">
-              <a:lnSpc>
-                <a:spcPct val="100000"/>
-              </a:lnSpc>
-              <a:defRPr sz="1000" b="0" i="0">
-                <a:solidFill>
-                  <a:srgbClr val="64748B"/>
-                </a:solidFill>
-                <a:latin typeface="Helvetica Neue"/>
-              </a:defRPr>
-            </a:pPr>
-            <a:r>
-              <a:t>AgentCore in Action · Article 0</a:t>
-            </a:r>
-          </a:p>
-        </p:txBody>
-      </p:sp>
-      <p:sp>
-        <p:nvSpPr>
-          <p:cNvPr id="9" name="TextBox 8"/>
-          <p:cNvSpPr txBox="1"/>
-          <p:nvPr/>
-        </p:nvSpPr>
-        <p:spPr>
-          <a:xfrm>
-            <a:off x="10881360" y="6510528"/>
-            <a:ext cx="777240" cy="274320"/>
-          </a:xfrm>
-          <a:prstGeom prst="rect">
-            <a:avLst/>
-          </a:prstGeom>
-          <a:noFill/>
-        </p:spPr>
-        <p:txBody>
-          <a:bodyPr wrap="square" anchor="t">
-            <a:spAutoFit/>
-          </a:bodyPr>
-          <a:lstStyle/>
-          <a:p>
-            <a:pPr algn="r">
-              <a:lnSpc>
-                <a:spcPct val="100000"/>
-              </a:lnSpc>
-              <a:defRPr sz="1000" b="0" i="0">
-                <a:solidFill>
-                  <a:srgbClr val="64748B"/>
-                </a:solidFill>
-                <a:latin typeface="Helvetica Neue"/>
-              </a:defRPr>
-            </a:pPr>
-            <a:r>
-              <a:t>22</a:t>
-            </a:r>
-          </a:p>
-        </p:txBody>
-      </p:sp>
-    </p:spTree>
-  </p:cSld>
-  <p:clrMapOvr>
-    <a:masterClrMapping/>
-  </p:clrMapOvr>
-</p:sld>
-</file>
-
-<file path=ppt/slides/slide23.xml><?xml version="1.0" encoding="utf-8"?>
-<p:sld xmlns:a="http://schemas.openxmlformats.org/drawingml/2006/main" xmlns:p="http://schemas.openxmlformats.org/presentationml/2006/main" xmlns:r="http://schemas.openxmlformats.org/officeDocument/2006/relationships">
-  <p:cSld>
-    <p:bg>
-      <p:bgPr>
         <a:gradFill rotWithShape="1">
           <a:gsLst>
             <a:gs pos="0">
@@ -13643,46 +13323,7 @@
               </a:defRPr>
             </a:pPr>
             <a:r>
-              <a:t>Next article: Your First Bedrock AgentCore Agent (A1)</a:t>
-            </a:r>
-          </a:p>
-        </p:txBody>
-      </p:sp>
-      <p:sp>
-        <p:nvSpPr>
-          <p:cNvPr id="6" name="TextBox 5"/>
-          <p:cNvSpPr txBox="1"/>
-          <p:nvPr/>
-        </p:nvSpPr>
-        <p:spPr>
-          <a:xfrm>
-            <a:off x="822960" y="5166360"/>
-            <a:ext cx="10515600" cy="457200"/>
-          </a:xfrm>
-          <a:prstGeom prst="rect">
-            <a:avLst/>
-          </a:prstGeom>
-          <a:noFill/>
-        </p:spPr>
-        <p:txBody>
-          <a:bodyPr wrap="square" anchor="t">
-            <a:spAutoFit/>
-          </a:bodyPr>
-          <a:lstStyle/>
-          <a:p>
-            <a:pPr algn="l">
-              <a:lnSpc>
-                <a:spcPct val="100000"/>
-              </a:lnSpc>
-              <a:defRPr sz="1400" b="0" i="0">
-                <a:solidFill>
-                  <a:srgbClr val="94A3B8"/>
-                </a:solidFill>
-                <a:latin typeface="Helvetica Neue"/>
-              </a:defRPr>
-            </a:pPr>
-            <a:r>
-              <a:t>AgentCore Series · Article 0 of 8 · xiongpin.dev</a:t>
+              <a:t>AgentCore in Action · Article 0 · xiongpin.dev</a:t>
             </a:r>
           </a:p>
         </p:txBody>

</xml_diff>

<commit_message>
a0 deck polish: fix occlusion, vertical centering, font sizes
- S6: removed slide-level rule text that overlapped the figure's own banner
- S19: shrunk/centered F6 so the caveat line no longer covers the figure
- dark_code panels and side cards now vertically centered (S3/S13/S14/S18)
- ACT divider: one-line ACT label
- font bumps: agenda items, env table, step-1 notes, deploy output (16pt),
  failure cards, cost descriptions; quote banner centered
</commit_message>
<xml_diff>
--- a/articles/decks/aws-agentcore-under-the-hood.pptx
+++ b/articles/decks/aws-agentcore-under-the-hood.pptx
@@ -4612,7 +4612,7 @@
         </p:blipFill>
         <p:spPr>
           <a:xfrm>
-            <a:off x="3154680" y="1920240"/>
+            <a:off x="2852928" y="1920240"/>
             <a:ext cx="6492240" cy="3859276"/>
           </a:xfrm>
           <a:prstGeom prst="rect">
@@ -5017,7 +5017,7 @@
               <a:lnSpc>
                 <a:spcPct val="112000"/>
               </a:lnSpc>
-              <a:defRPr sz="1500">
+              <a:defRPr sz="1600">
                 <a:solidFill>
                   <a:srgbClr val="34D399"/>
                 </a:solidFill>
@@ -5033,7 +5033,7 @@
               <a:lnSpc>
                 <a:spcPct val="112000"/>
               </a:lnSpc>
-              <a:defRPr sz="1500">
+              <a:defRPr sz="1600">
                 <a:solidFill>
                   <a:srgbClr val="E2E8F0"/>
                 </a:solidFill>
@@ -5049,7 +5049,7 @@
               <a:lnSpc>
                 <a:spcPct val="112000"/>
               </a:lnSpc>
-              <a:defRPr sz="1500">
+              <a:defRPr sz="1600">
                 <a:solidFill>
                   <a:srgbClr val="E2E8F0"/>
                 </a:solidFill>
@@ -5065,7 +5065,7 @@
               <a:lnSpc>
                 <a:spcPct val="112000"/>
               </a:lnSpc>
-              <a:defRPr sz="1500">
+              <a:defRPr sz="1600">
                 <a:solidFill>
                   <a:srgbClr val="E2E8F0"/>
                 </a:solidFill>
@@ -5081,7 +5081,7 @@
               <a:lnSpc>
                 <a:spcPct val="112000"/>
               </a:lnSpc>
-              <a:defRPr sz="1500">
+              <a:defRPr sz="1600">
                 <a:solidFill>
                   <a:srgbClr val="E2E8F0"/>
                 </a:solidFill>
@@ -5097,7 +5097,7 @@
               <a:lnSpc>
                 <a:spcPct val="112000"/>
               </a:lnSpc>
-              <a:defRPr sz="1500">
+              <a:defRPr sz="1600">
                 <a:solidFill>
                   <a:srgbClr val="E2E8F0"/>
                 </a:solidFill>
@@ -5113,7 +5113,7 @@
               <a:lnSpc>
                 <a:spcPct val="112000"/>
               </a:lnSpc>
-              <a:defRPr sz="1500">
+              <a:defRPr sz="1600">
                 <a:solidFill>
                   <a:srgbClr val="E2E8F0"/>
                 </a:solidFill>
@@ -5129,7 +5129,7 @@
               <a:lnSpc>
                 <a:spcPct val="112000"/>
               </a:lnSpc>
-              <a:defRPr sz="1500">
+              <a:defRPr sz="1600">
                 <a:solidFill>
                   <a:srgbClr val="E2E8F0"/>
                 </a:solidFill>
@@ -5145,7 +5145,7 @@
               <a:lnSpc>
                 <a:spcPct val="112000"/>
               </a:lnSpc>
-              <a:defRPr sz="1500">
+              <a:defRPr sz="1600">
                 <a:solidFill>
                   <a:srgbClr val="93C5FD"/>
                 </a:solidFill>
@@ -5161,7 +5161,7 @@
               <a:lnSpc>
                 <a:spcPct val="112000"/>
               </a:lnSpc>
-              <a:defRPr sz="1500">
+              <a:defRPr sz="1600">
                 <a:solidFill>
                   <a:srgbClr val="93C5FD"/>
                 </a:solidFill>
@@ -5177,7 +5177,7 @@
               <a:lnSpc>
                 <a:spcPct val="112000"/>
               </a:lnSpc>
-              <a:defRPr sz="1500">
+              <a:defRPr sz="1600">
                 <a:solidFill>
                   <a:srgbClr val="E2E8F0"/>
                 </a:solidFill>
@@ -5190,7 +5190,7 @@
               <a:lnSpc>
                 <a:spcPct val="112000"/>
               </a:lnSpc>
-              <a:defRPr sz="1500">
+              <a:defRPr sz="1600">
                 <a:solidFill>
                   <a:srgbClr val="94A3B8"/>
                 </a:solidFill>
@@ -5791,8 +5791,8 @@
         </p:nvSpPr>
         <p:spPr>
           <a:xfrm>
-            <a:off x="8275320" y="2286000"/>
-            <a:ext cx="3108960" cy="3291840"/>
+            <a:off x="8275320" y="2011680"/>
+            <a:ext cx="3108960" cy="3749039"/>
           </a:xfrm>
           <a:prstGeom prst="rect">
             <a:avLst/>
@@ -5800,7 +5800,7 @@
           <a:noFill/>
         </p:spPr>
         <p:txBody>
-          <a:bodyPr wrap="square" anchor="t">
+          <a:bodyPr wrap="square" anchor="ctr">
             <a:spAutoFit/>
           </a:bodyPr>
           <a:lstStyle/>
@@ -6563,8 +6563,8 @@
         </p:nvSpPr>
         <p:spPr>
           <a:xfrm>
-            <a:off x="6949440" y="2286000"/>
-            <a:ext cx="4663440" cy="3291840"/>
+            <a:off x="6949440" y="2011680"/>
+            <a:ext cx="4663440" cy="3794760"/>
           </a:xfrm>
           <a:prstGeom prst="rect">
             <a:avLst/>
@@ -6572,7 +6572,7 @@
           <a:noFill/>
         </p:spPr>
         <p:txBody>
-          <a:bodyPr wrap="square" anchor="t">
+          <a:bodyPr wrap="square" anchor="ctr">
             <a:spAutoFit/>
           </a:bodyPr>
           <a:lstStyle/>
@@ -7656,7 +7656,7 @@
               <a:lnSpc>
                 <a:spcPct val="115000"/>
               </a:lnSpc>
-              <a:defRPr sz="1250" b="0" i="0">
+              <a:defRPr sz="1300" b="0" i="0">
                 <a:solidFill>
                   <a:srgbClr val="475569"/>
                 </a:solidFill>
@@ -7672,7 +7672,7 @@
               <a:lnSpc>
                 <a:spcPct val="115000"/>
               </a:lnSpc>
-              <a:defRPr sz="1250" b="0" i="0">
+              <a:defRPr sz="1300" b="0" i="0">
                 <a:solidFill>
                   <a:srgbClr val="475569"/>
                 </a:solidFill>
@@ -7883,7 +7883,7 @@
               <a:lnSpc>
                 <a:spcPct val="115000"/>
               </a:lnSpc>
-              <a:defRPr sz="1250" b="0" i="0">
+              <a:defRPr sz="1300" b="0" i="0">
                 <a:solidFill>
                   <a:srgbClr val="475569"/>
                 </a:solidFill>
@@ -7899,7 +7899,7 @@
               <a:lnSpc>
                 <a:spcPct val="115000"/>
               </a:lnSpc>
-              <a:defRPr sz="1250" b="0" i="0">
+              <a:defRPr sz="1300" b="0" i="0">
                 <a:solidFill>
                   <a:srgbClr val="475569"/>
                 </a:solidFill>
@@ -8110,7 +8110,7 @@
               <a:lnSpc>
                 <a:spcPct val="115000"/>
               </a:lnSpc>
-              <a:defRPr sz="1250" b="0" i="0">
+              <a:defRPr sz="1300" b="0" i="0">
                 <a:solidFill>
                   <a:srgbClr val="475569"/>
                 </a:solidFill>
@@ -8126,7 +8126,7 @@
               <a:lnSpc>
                 <a:spcPct val="115000"/>
               </a:lnSpc>
-              <a:defRPr sz="1250" b="0" i="0">
+              <a:defRPr sz="1300" b="0" i="0">
                 <a:solidFill>
                   <a:srgbClr val="475569"/>
                 </a:solidFill>
@@ -8394,8 +8394,8 @@
         </p:nvSpPr>
         <p:spPr>
           <a:xfrm>
-            <a:off x="822960" y="1417320"/>
-            <a:ext cx="2926080" cy="1463040"/>
+            <a:off x="822960" y="2148840"/>
+            <a:ext cx="4572000" cy="914400"/>
           </a:xfrm>
           <a:prstGeom prst="rect">
             <a:avLst/>
@@ -8420,23 +8420,7 @@
               </a:defRPr>
             </a:pPr>
             <a:r>
-              <a:t>ACT</a:t>
-            </a:r>
-          </a:p>
-          <a:p>
-            <a:pPr algn="l">
-              <a:lnSpc>
-                <a:spcPct val="95000"/>
-              </a:lnSpc>
-              <a:defRPr sz="5400" b="1" i="0">
-                <a:solidFill>
-                  <a:srgbClr val="FFFFFF"/>
-                </a:solidFill>
-                <a:latin typeface="Helvetica Neue"/>
-              </a:defRPr>
-            </a:pPr>
-            <a:r>
-              <a:t>III</a:t>
+              <a:t>ACT III</a:t>
             </a:r>
           </a:p>
         </p:txBody>
@@ -8449,7 +8433,7 @@
         </p:nvSpPr>
         <p:spPr>
           <a:xfrm>
-            <a:off x="868680" y="3154680"/>
+            <a:off x="868680" y="3246120"/>
             <a:ext cx="1188720" cy="82296"/>
           </a:xfrm>
           <a:prstGeom prst="rect">
@@ -8501,8 +8485,8 @@
         </p:nvSpPr>
         <p:spPr>
           <a:xfrm>
-            <a:off x="822960" y="3429000"/>
-            <a:ext cx="5943600" cy="822960"/>
+            <a:off x="822960" y="3520440"/>
+            <a:ext cx="4937760" cy="822960"/>
           </a:xfrm>
           <a:prstGeom prst="rect">
             <a:avLst/>
@@ -9466,8 +9450,8 @@
         </p:nvSpPr>
         <p:spPr>
           <a:xfrm>
-            <a:off x="8092440" y="2286000"/>
-            <a:ext cx="3291840" cy="3383280"/>
+            <a:off x="8092440" y="2011680"/>
+            <a:ext cx="3291840" cy="3749039"/>
           </a:xfrm>
           <a:prstGeom prst="rect">
             <a:avLst/>
@@ -9475,7 +9459,7 @@
           <a:noFill/>
         </p:spPr>
         <p:txBody>
-          <a:bodyPr wrap="square" anchor="t">
+          <a:bodyPr wrap="square" anchor="ctr">
             <a:spAutoFit/>
           </a:bodyPr>
           <a:lstStyle/>
@@ -9959,8 +9943,8 @@
         </p:blipFill>
         <p:spPr>
           <a:xfrm>
-            <a:off x="3063240" y="1920240"/>
-            <a:ext cx="6400800" cy="4427220"/>
+            <a:off x="3172968" y="1783080"/>
+            <a:ext cx="5852160" cy="4047744"/>
           </a:xfrm>
           <a:prstGeom prst="rect">
             <a:avLst/>
@@ -9993,7 +9977,7 @@
               <a:lnSpc>
                 <a:spcPct val="100000"/>
               </a:lnSpc>
-              <a:defRPr sz="1300" b="1" i="0">
+              <a:defRPr sz="1350" b="1" i="0">
                 <a:solidFill>
                   <a:srgbClr val="BE123C"/>
                 </a:solidFill>
@@ -10460,7 +10444,7 @@
               <a:lnSpc>
                 <a:spcPct val="105000"/>
               </a:lnSpc>
-              <a:defRPr sz="1250" b="0" i="0">
+              <a:defRPr sz="1350" b="0" i="0">
                 <a:solidFill>
                   <a:srgbClr val="475569"/>
                 </a:solidFill>
@@ -10499,7 +10483,7 @@
               <a:lnSpc>
                 <a:spcPct val="100000"/>
               </a:lnSpc>
-              <a:defRPr sz="1200" b="0" i="0">
+              <a:defRPr sz="1350" b="0" i="0">
                 <a:solidFill>
                   <a:srgbClr val="0F172A"/>
                 </a:solidFill>
@@ -10520,7 +10504,7 @@
         </p:nvSpPr>
         <p:spPr>
           <a:xfrm>
-            <a:off x="868680" y="4361688"/>
+            <a:off x="868680" y="4398264"/>
             <a:ext cx="2971800" cy="548640"/>
           </a:xfrm>
           <a:prstGeom prst="rect">
@@ -10538,7 +10522,7 @@
               <a:lnSpc>
                 <a:spcPct val="100000"/>
               </a:lnSpc>
-              <a:defRPr sz="1200" b="0" i="0">
+              <a:defRPr sz="1350" b="0" i="0">
                 <a:solidFill>
                   <a:srgbClr val="0F172A"/>
                 </a:solidFill>
@@ -10710,7 +10694,7 @@
               <a:lnSpc>
                 <a:spcPct val="105000"/>
               </a:lnSpc>
-              <a:defRPr sz="1250" b="0" i="0">
+              <a:defRPr sz="1350" b="0" i="0">
                 <a:solidFill>
                   <a:srgbClr val="475569"/>
                 </a:solidFill>
@@ -10749,7 +10733,7 @@
               <a:lnSpc>
                 <a:spcPct val="100000"/>
               </a:lnSpc>
-              <a:defRPr sz="1200" b="0" i="0">
+              <a:defRPr sz="1350" b="0" i="0">
                 <a:solidFill>
                   <a:srgbClr val="0F172A"/>
                 </a:solidFill>
@@ -10770,7 +10754,7 @@
         </p:nvSpPr>
         <p:spPr>
           <a:xfrm>
-            <a:off x="4663440" y="4361688"/>
+            <a:off x="4663440" y="4398264"/>
             <a:ext cx="2971800" cy="548640"/>
           </a:xfrm>
           <a:prstGeom prst="rect">
@@ -10788,7 +10772,7 @@
               <a:lnSpc>
                 <a:spcPct val="100000"/>
               </a:lnSpc>
-              <a:defRPr sz="1200" b="0" i="0">
+              <a:defRPr sz="1350" b="0" i="0">
                 <a:solidFill>
                   <a:srgbClr val="0F172A"/>
                 </a:solidFill>
@@ -10960,7 +10944,7 @@
               <a:lnSpc>
                 <a:spcPct val="105000"/>
               </a:lnSpc>
-              <a:defRPr sz="1250" b="0" i="0">
+              <a:defRPr sz="1350" b="0" i="0">
                 <a:solidFill>
                   <a:srgbClr val="475569"/>
                 </a:solidFill>
@@ -10999,7 +10983,7 @@
               <a:lnSpc>
                 <a:spcPct val="100000"/>
               </a:lnSpc>
-              <a:defRPr sz="1200" b="0" i="0">
+              <a:defRPr sz="1350" b="0" i="0">
                 <a:solidFill>
                   <a:srgbClr val="0F172A"/>
                 </a:solidFill>
@@ -11020,7 +11004,7 @@
         </p:nvSpPr>
         <p:spPr>
           <a:xfrm>
-            <a:off x="8458200" y="4361688"/>
+            <a:off x="8458200" y="4398264"/>
             <a:ext cx="2971800" cy="548640"/>
           </a:xfrm>
           <a:prstGeom prst="rect">
@@ -11038,7 +11022,7 @@
               <a:lnSpc>
                 <a:spcPct val="100000"/>
               </a:lnSpc>
-              <a:defRPr sz="1200" b="0" i="0">
+              <a:defRPr sz="1350" b="0" i="0">
                 <a:solidFill>
                   <a:srgbClr val="0F172A"/>
                 </a:solidFill>
@@ -11448,7 +11432,7 @@
         </p:nvSpPr>
         <p:spPr>
           <a:xfrm>
-            <a:off x="868680" y="2212848"/>
+            <a:off x="868680" y="2194560"/>
             <a:ext cx="4846320" cy="502920"/>
           </a:xfrm>
           <a:prstGeom prst="rect">
@@ -11466,7 +11450,7 @@
               <a:lnSpc>
                 <a:spcPct val="100000"/>
               </a:lnSpc>
-              <a:defRPr sz="1550" b="1" i="0">
+              <a:defRPr sz="1650" b="1" i="0">
                 <a:solidFill>
                   <a:srgbClr val="0F172A"/>
                 </a:solidFill>
@@ -11505,7 +11489,7 @@
               <a:lnSpc>
                 <a:spcPct val="112000"/>
               </a:lnSpc>
-              <a:defRPr sz="1250" b="0" i="0">
+              <a:defRPr sz="1350" b="0" i="0">
                 <a:solidFill>
                   <a:srgbClr val="475569"/>
                 </a:solidFill>
@@ -11620,7 +11604,7 @@
         </p:nvSpPr>
         <p:spPr>
           <a:xfrm>
-            <a:off x="6492240" y="2212848"/>
+            <a:off x="6492240" y="2194560"/>
             <a:ext cx="4846320" cy="502920"/>
           </a:xfrm>
           <a:prstGeom prst="rect">
@@ -11638,7 +11622,7 @@
               <a:lnSpc>
                 <a:spcPct val="100000"/>
               </a:lnSpc>
-              <a:defRPr sz="1550" b="1" i="0">
+              <a:defRPr sz="1650" b="1" i="0">
                 <a:solidFill>
                   <a:srgbClr val="0F172A"/>
                 </a:solidFill>
@@ -11677,7 +11661,7 @@
               <a:lnSpc>
                 <a:spcPct val="112000"/>
               </a:lnSpc>
-              <a:defRPr sz="1250" b="0" i="0">
+              <a:defRPr sz="1350" b="0" i="0">
                 <a:solidFill>
                   <a:srgbClr val="475569"/>
                 </a:solidFill>
@@ -11792,7 +11776,7 @@
         </p:nvSpPr>
         <p:spPr>
           <a:xfrm>
-            <a:off x="868680" y="4315968"/>
+            <a:off x="868680" y="4297680"/>
             <a:ext cx="4846320" cy="502920"/>
           </a:xfrm>
           <a:prstGeom prst="rect">
@@ -11810,7 +11794,7 @@
               <a:lnSpc>
                 <a:spcPct val="100000"/>
               </a:lnSpc>
-              <a:defRPr sz="1550" b="1" i="0">
+              <a:defRPr sz="1650" b="1" i="0">
                 <a:solidFill>
                   <a:srgbClr val="0F172A"/>
                 </a:solidFill>
@@ -11849,7 +11833,7 @@
               <a:lnSpc>
                 <a:spcPct val="112000"/>
               </a:lnSpc>
-              <a:defRPr sz="1250" b="0" i="0">
+              <a:defRPr sz="1350" b="0" i="0">
                 <a:solidFill>
                   <a:srgbClr val="475569"/>
                 </a:solidFill>
@@ -11964,7 +11948,7 @@
         </p:nvSpPr>
         <p:spPr>
           <a:xfrm>
-            <a:off x="6492240" y="4315968"/>
+            <a:off x="6492240" y="4297680"/>
             <a:ext cx="4846320" cy="502920"/>
           </a:xfrm>
           <a:prstGeom prst="rect">
@@ -11982,7 +11966,7 @@
               <a:lnSpc>
                 <a:spcPct val="100000"/>
               </a:lnSpc>
-              <a:defRPr sz="1550" b="1" i="0">
+              <a:defRPr sz="1650" b="1" i="0">
                 <a:solidFill>
                   <a:srgbClr val="0F172A"/>
                 </a:solidFill>
@@ -12021,7 +12005,7 @@
               <a:lnSpc>
                 <a:spcPct val="112000"/>
               </a:lnSpc>
-              <a:defRPr sz="1250" b="0" i="0">
+              <a:defRPr sz="1350" b="0" i="0">
                 <a:solidFill>
                   <a:srgbClr val="475569"/>
                 </a:solidFill>
@@ -12943,8 +12927,8 @@
         </p:nvSpPr>
         <p:spPr>
           <a:xfrm>
-            <a:off x="1783080" y="5815584"/>
-            <a:ext cx="9144000" cy="411480"/>
+            <a:off x="1508760" y="5715000"/>
+            <a:ext cx="9692640" cy="594360"/>
           </a:xfrm>
           <a:prstGeom prst="rect">
             <a:avLst/>
@@ -12952,12 +12936,12 @@
           <a:noFill/>
         </p:spPr>
         <p:txBody>
-          <a:bodyPr wrap="square" anchor="t">
+          <a:bodyPr wrap="square" anchor="ctr">
             <a:spAutoFit/>
           </a:bodyPr>
           <a:lstStyle/>
           <a:p>
-            <a:pPr algn="l">
+            <a:pPr algn="ctr">
               <a:lnSpc>
                 <a:spcPct val="100000"/>
               </a:lnSpc>
@@ -13642,8 +13626,8 @@
         </p:nvSpPr>
         <p:spPr>
           <a:xfrm>
-            <a:off x="914400" y="2971800"/>
-            <a:ext cx="4663440" cy="2377440"/>
+            <a:off x="914400" y="2743200"/>
+            <a:ext cx="4663440" cy="2926080"/>
           </a:xfrm>
           <a:prstGeom prst="rect">
             <a:avLst/>
@@ -13651,7 +13635,7 @@
           <a:noFill/>
         </p:spPr>
         <p:txBody>
-          <a:bodyPr wrap="square" anchor="t">
+          <a:bodyPr wrap="square" anchor="ctr">
             <a:spAutoFit/>
           </a:bodyPr>
           <a:lstStyle/>
@@ -13862,8 +13846,92 @@
         </p:nvSpPr>
         <p:spPr>
           <a:xfrm>
-            <a:off x="6675120" y="2971800"/>
-            <a:ext cx="4663440" cy="1828800"/>
+            <a:off x="6675120" y="2743200"/>
+            <a:ext cx="4663440" cy="2926080"/>
+          </a:xfrm>
+          <a:prstGeom prst="rect">
+            <a:avLst/>
+          </a:prstGeom>
+          <a:noFill/>
+        </p:spPr>
+        <p:txBody>
+          <a:bodyPr wrap="square" anchor="ctr">
+            <a:spAutoFit/>
+          </a:bodyPr>
+          <a:lstStyle/>
+          <a:p>
+            <a:pPr algn="l">
+              <a:lnSpc>
+                <a:spcPct val="150000"/>
+              </a:lnSpc>
+              <a:defRPr sz="1700" b="0" i="0">
+                <a:solidFill>
+                  <a:srgbClr val="0F172A"/>
+                </a:solidFill>
+                <a:latin typeface="Helvetica Neue"/>
+              </a:defRPr>
+            </a:pPr>
+            <a:r>
+              <a:t>One JSON file</a:t>
+            </a:r>
+          </a:p>
+          <a:p>
+            <a:pPr algn="l">
+              <a:lnSpc>
+                <a:spcPct val="150000"/>
+              </a:lnSpc>
+              <a:defRPr sz="1700" b="0" i="0">
+                <a:solidFill>
+                  <a:srgbClr val="0F172A"/>
+                </a:solidFill>
+                <a:latin typeface="Helvetica Neue"/>
+              </a:defRPr>
+            </a:pPr>
+            <a:r>
+              <a:t>One command</a:t>
+            </a:r>
+          </a:p>
+          <a:p>
+            <a:pPr algn="l">
+              <a:lnSpc>
+                <a:spcPct val="150000"/>
+              </a:lnSpc>
+              <a:defRPr sz="1700" b="0" i="0">
+                <a:solidFill>
+                  <a:srgbClr val="0F172A"/>
+                </a:solidFill>
+                <a:latin typeface="Helvetica Neue"/>
+              </a:defRPr>
+            </a:pPr>
+          </a:p>
+          <a:p>
+            <a:pPr algn="l">
+              <a:lnSpc>
+                <a:spcPct val="150000"/>
+              </a:lnSpc>
+              <a:defRPr sz="1700" b="0" i="0">
+                <a:solidFill>
+                  <a:srgbClr val="0F172A"/>
+                </a:solidFill>
+                <a:latin typeface="Helvetica Neue"/>
+              </a:defRPr>
+            </a:pPr>
+            <a:r>
+              <a:t>A running, observable endpoint</a:t>
+            </a:r>
+          </a:p>
+        </p:txBody>
+      </p:sp>
+      <p:sp>
+        <p:nvSpPr>
+          <p:cNvPr id="13" name="TextBox 12"/>
+          <p:cNvSpPr txBox="1"/>
+          <p:nvPr/>
+        </p:nvSpPr>
+        <p:spPr>
+          <a:xfrm>
+            <a:off x="548640" y="6035040"/>
+            <a:ext cx="11091672" cy="365760"/>
           </a:xfrm>
           <a:prstGeom prst="rect">
             <a:avLst/>
@@ -13876,95 +13944,11 @@
           </a:bodyPr>
           <a:lstStyle/>
           <a:p>
-            <a:pPr algn="l">
-              <a:lnSpc>
-                <a:spcPct val="150000"/>
-              </a:lnSpc>
-              <a:defRPr sz="1700" b="0" i="0">
-                <a:solidFill>
-                  <a:srgbClr val="0F172A"/>
-                </a:solidFill>
-                <a:latin typeface="Helvetica Neue"/>
-              </a:defRPr>
-            </a:pPr>
-            <a:r>
-              <a:t>One JSON file</a:t>
-            </a:r>
-          </a:p>
-          <a:p>
-            <a:pPr algn="l">
-              <a:lnSpc>
-                <a:spcPct val="150000"/>
-              </a:lnSpc>
-              <a:defRPr sz="1700" b="0" i="0">
-                <a:solidFill>
-                  <a:srgbClr val="0F172A"/>
-                </a:solidFill>
-                <a:latin typeface="Helvetica Neue"/>
-              </a:defRPr>
-            </a:pPr>
-            <a:r>
-              <a:t>One command</a:t>
-            </a:r>
-          </a:p>
-          <a:p>
-            <a:pPr algn="l">
-              <a:lnSpc>
-                <a:spcPct val="150000"/>
-              </a:lnSpc>
-              <a:defRPr sz="1700" b="0" i="0">
-                <a:solidFill>
-                  <a:srgbClr val="0F172A"/>
-                </a:solidFill>
-                <a:latin typeface="Helvetica Neue"/>
-              </a:defRPr>
-            </a:pPr>
-          </a:p>
-          <a:p>
-            <a:pPr algn="l">
-              <a:lnSpc>
-                <a:spcPct val="150000"/>
-              </a:lnSpc>
-              <a:defRPr sz="1700" b="0" i="0">
-                <a:solidFill>
-                  <a:srgbClr val="0F172A"/>
-                </a:solidFill>
-                <a:latin typeface="Helvetica Neue"/>
-              </a:defRPr>
-            </a:pPr>
-            <a:r>
-              <a:t>A running, observable endpoint</a:t>
-            </a:r>
-          </a:p>
-        </p:txBody>
-      </p:sp>
-      <p:sp>
-        <p:nvSpPr>
-          <p:cNvPr id="13" name="TextBox 12"/>
-          <p:cNvSpPr txBox="1"/>
-          <p:nvPr/>
-        </p:nvSpPr>
-        <p:spPr>
-          <a:xfrm>
-            <a:off x="6309360" y="6035040"/>
-            <a:ext cx="5349240" cy="365760"/>
-          </a:xfrm>
-          <a:prstGeom prst="rect">
-            <a:avLst/>
-          </a:prstGeom>
-          <a:noFill/>
-        </p:spPr>
-        <p:txBody>
-          <a:bodyPr wrap="square" anchor="t">
-            <a:spAutoFit/>
-          </a:bodyPr>
-          <a:lstStyle/>
-          <a:p>
             <a:pPr algn="ctr">
               <a:lnSpc>
                 <a:spcPct val="100000"/>
               </a:lnSpc>
-              <a:defRPr sz="1200" b="0" i="1">
+              <a:defRPr sz="1300" b="0" i="1">
                 <a:solidFill>
                   <a:srgbClr val="64748B"/>
                 </a:solidFill>
@@ -14193,8 +14177,8 @@
         </p:nvSpPr>
         <p:spPr>
           <a:xfrm>
-            <a:off x="822960" y="1417320"/>
-            <a:ext cx="2926080" cy="1463040"/>
+            <a:off x="822960" y="2148840"/>
+            <a:ext cx="4572000" cy="914400"/>
           </a:xfrm>
           <a:prstGeom prst="rect">
             <a:avLst/>
@@ -14219,23 +14203,7 @@
               </a:defRPr>
             </a:pPr>
             <a:r>
-              <a:t>ACT</a:t>
-            </a:r>
-          </a:p>
-          <a:p>
-            <a:pPr algn="l">
-              <a:lnSpc>
-                <a:spcPct val="95000"/>
-              </a:lnSpc>
-              <a:defRPr sz="5400" b="1" i="0">
-                <a:solidFill>
-                  <a:srgbClr val="FFFFFF"/>
-                </a:solidFill>
-                <a:latin typeface="Helvetica Neue"/>
-              </a:defRPr>
-            </a:pPr>
-            <a:r>
-              <a:t>I</a:t>
+              <a:t>ACT I</a:t>
             </a:r>
           </a:p>
         </p:txBody>
@@ -14248,7 +14216,7 @@
         </p:nvSpPr>
         <p:spPr>
           <a:xfrm>
-            <a:off x="868680" y="3154680"/>
+            <a:off x="868680" y="3246120"/>
             <a:ext cx="1188720" cy="82296"/>
           </a:xfrm>
           <a:prstGeom prst="rect">
@@ -14300,8 +14268,8 @@
         </p:nvSpPr>
         <p:spPr>
           <a:xfrm>
-            <a:off x="822960" y="3429000"/>
-            <a:ext cx="5943600" cy="822960"/>
+            <a:off x="822960" y="3520440"/>
+            <a:ext cx="4937760" cy="822960"/>
           </a:xfrm>
           <a:prstGeom prst="rect">
             <a:avLst/>
@@ -14811,8 +14779,8 @@
         </p:blipFill>
         <p:spPr>
           <a:xfrm>
-            <a:off x="3703320" y="2103120"/>
-            <a:ext cx="5486400" cy="4343400"/>
+            <a:off x="3081528" y="2103120"/>
+            <a:ext cx="6035040" cy="4777740"/>
           </a:xfrm>
           <a:prstGeom prst="rect">
             <a:avLst/>
@@ -15130,7 +15098,7 @@
         </p:blipFill>
         <p:spPr>
           <a:xfrm>
-            <a:off x="3246120" y="1965960"/>
+            <a:off x="2944368" y="1965960"/>
             <a:ext cx="6309360" cy="4604956"/>
           </a:xfrm>
           <a:prstGeom prst="rect">
@@ -15140,46 +15108,7 @@
       </p:pic>
       <p:sp>
         <p:nvSpPr>
-          <p:cNvPr id="6" name="TextBox 5"/>
-          <p:cNvSpPr txBox="1"/>
-          <p:nvPr/>
-        </p:nvSpPr>
-        <p:spPr>
-          <a:xfrm>
-            <a:off x="548640" y="5989320"/>
-            <a:ext cx="11064240" cy="411480"/>
-          </a:xfrm>
-          <a:prstGeom prst="rect">
-            <a:avLst/>
-          </a:prstGeom>
-          <a:noFill/>
-        </p:spPr>
-        <p:txBody>
-          <a:bodyPr wrap="square" anchor="t">
-            <a:spAutoFit/>
-          </a:bodyPr>
-          <a:lstStyle/>
-          <a:p>
-            <a:pPr algn="ctr">
-              <a:lnSpc>
-                <a:spcPct val="100000"/>
-              </a:lnSpc>
-              <a:defRPr sz="1500" b="1" i="0">
-                <a:solidFill>
-                  <a:srgbClr val="0F172A"/>
-                </a:solidFill>
-                <a:latin typeface="Helvetica Neue"/>
-              </a:defRPr>
-            </a:pPr>
-            <a:r>
-              <a:t>Rule: declare in JSON. Everything generated is regenerable.</a:t>
-            </a:r>
-          </a:p>
-        </p:txBody>
-      </p:sp>
-      <p:sp>
-        <p:nvSpPr>
-          <p:cNvPr id="7" name="Rectangle 6"/>
+          <p:cNvPr id="6" name="Rectangle 5"/>
           <p:cNvSpPr/>
           <p:nvPr/>
         </p:nvSpPr>
@@ -15223,7 +15152,7 @@
       </p:sp>
       <p:sp>
         <p:nvSpPr>
-          <p:cNvPr id="8" name="TextBox 7"/>
+          <p:cNvPr id="7" name="TextBox 6"/>
           <p:cNvSpPr txBox="1"/>
           <p:nvPr/>
         </p:nvSpPr>
@@ -15262,7 +15191,7 @@
       </p:sp>
       <p:sp>
         <p:nvSpPr>
-          <p:cNvPr id="9" name="TextBox 8"/>
+          <p:cNvPr id="8" name="TextBox 7"/>
           <p:cNvSpPr txBox="1"/>
           <p:nvPr/>
         </p:nvSpPr>
@@ -15393,8 +15322,8 @@
         </p:nvSpPr>
         <p:spPr>
           <a:xfrm>
-            <a:off x="822960" y="1417320"/>
-            <a:ext cx="2926080" cy="1463040"/>
+            <a:off x="822960" y="2148840"/>
+            <a:ext cx="4572000" cy="914400"/>
           </a:xfrm>
           <a:prstGeom prst="rect">
             <a:avLst/>
@@ -15419,23 +15348,7 @@
               </a:defRPr>
             </a:pPr>
             <a:r>
-              <a:t>ACT</a:t>
-            </a:r>
-          </a:p>
-          <a:p>
-            <a:pPr algn="l">
-              <a:lnSpc>
-                <a:spcPct val="95000"/>
-              </a:lnSpc>
-              <a:defRPr sz="5400" b="1" i="0">
-                <a:solidFill>
-                  <a:srgbClr val="FFFFFF"/>
-                </a:solidFill>
-                <a:latin typeface="Helvetica Neue"/>
-              </a:defRPr>
-            </a:pPr>
-            <a:r>
-              <a:t>II</a:t>
+              <a:t>ACT II</a:t>
             </a:r>
           </a:p>
         </p:txBody>
@@ -15448,7 +15361,7 @@
         </p:nvSpPr>
         <p:spPr>
           <a:xfrm>
-            <a:off x="868680" y="3154680"/>
+            <a:off x="868680" y="3246120"/>
             <a:ext cx="1188720" cy="82296"/>
           </a:xfrm>
           <a:prstGeom prst="rect">
@@ -15500,8 +15413,8 @@
         </p:nvSpPr>
         <p:spPr>
           <a:xfrm>
-            <a:off x="822960" y="3429000"/>
-            <a:ext cx="5943600" cy="822960"/>
+            <a:off x="822960" y="3520440"/>
+            <a:ext cx="4937760" cy="822960"/>
           </a:xfrm>
           <a:prstGeom prst="rect">
             <a:avLst/>
@@ -16493,7 +16406,7 @@
               <a:lnSpc>
                 <a:spcPct val="100000"/>
               </a:lnSpc>
-              <a:defRPr sz="1300" b="1" i="0">
+              <a:defRPr sz="1400" b="1" i="0">
                 <a:solidFill>
                   <a:srgbClr val="0F172A"/>
                 </a:solidFill>
@@ -16532,7 +16445,7 @@
               <a:lnSpc>
                 <a:spcPct val="100000"/>
               </a:lnSpc>
-              <a:defRPr sz="1300" b="0" i="0">
+              <a:defRPr sz="1400" b="0" i="0">
                 <a:solidFill>
                   <a:srgbClr val="475569"/>
                 </a:solidFill>
@@ -16571,7 +16484,7 @@
               <a:lnSpc>
                 <a:spcPct val="100000"/>
               </a:lnSpc>
-              <a:defRPr sz="1300" b="1" i="0">
+              <a:defRPr sz="1400" b="1" i="0">
                 <a:solidFill>
                   <a:srgbClr val="0F172A"/>
                 </a:solidFill>
@@ -16610,7 +16523,7 @@
               <a:lnSpc>
                 <a:spcPct val="100000"/>
               </a:lnSpc>
-              <a:defRPr sz="1300" b="0" i="0">
+              <a:defRPr sz="1400" b="0" i="0">
                 <a:solidFill>
                   <a:srgbClr val="475569"/>
                 </a:solidFill>
@@ -16649,7 +16562,7 @@
               <a:lnSpc>
                 <a:spcPct val="100000"/>
               </a:lnSpc>
-              <a:defRPr sz="1300" b="1" i="0">
+              <a:defRPr sz="1400" b="1" i="0">
                 <a:solidFill>
                   <a:srgbClr val="0F172A"/>
                 </a:solidFill>
@@ -16688,7 +16601,7 @@
               <a:lnSpc>
                 <a:spcPct val="100000"/>
               </a:lnSpc>
-              <a:defRPr sz="1300" b="0" i="0">
+              <a:defRPr sz="1400" b="0" i="0">
                 <a:solidFill>
                   <a:srgbClr val="475569"/>
                 </a:solidFill>
@@ -16727,7 +16640,7 @@
               <a:lnSpc>
                 <a:spcPct val="100000"/>
               </a:lnSpc>
-              <a:defRPr sz="1300" b="1" i="0">
+              <a:defRPr sz="1400" b="1" i="0">
                 <a:solidFill>
                   <a:srgbClr val="0F172A"/>
                 </a:solidFill>
@@ -16766,7 +16679,7 @@
               <a:lnSpc>
                 <a:spcPct val="100000"/>
               </a:lnSpc>
-              <a:defRPr sz="1300" b="0" i="0">
+              <a:defRPr sz="1400" b="0" i="0">
                 <a:solidFill>
                   <a:srgbClr val="475569"/>
                 </a:solidFill>
@@ -16805,7 +16718,7 @@
               <a:lnSpc>
                 <a:spcPct val="100000"/>
               </a:lnSpc>
-              <a:defRPr sz="1300" b="1" i="0">
+              <a:defRPr sz="1400" b="1" i="0">
                 <a:solidFill>
                   <a:srgbClr val="0F172A"/>
                 </a:solidFill>
@@ -16844,7 +16757,7 @@
               <a:lnSpc>
                 <a:spcPct val="100000"/>
               </a:lnSpc>
-              <a:defRPr sz="1300" b="0" i="0">
+              <a:defRPr sz="1400" b="0" i="0">
                 <a:solidFill>
                   <a:srgbClr val="475569"/>
                 </a:solidFill>
@@ -16883,7 +16796,7 @@
               <a:lnSpc>
                 <a:spcPct val="100000"/>
               </a:lnSpc>
-              <a:defRPr sz="1300" b="1" i="0">
+              <a:defRPr sz="1400" b="1" i="0">
                 <a:solidFill>
                   <a:srgbClr val="0F172A"/>
                 </a:solidFill>
@@ -16922,7 +16835,7 @@
               <a:lnSpc>
                 <a:spcPct val="100000"/>
               </a:lnSpc>
-              <a:defRPr sz="1300" b="0" i="0">
+              <a:defRPr sz="1400" b="0" i="0">
                 <a:solidFill>
                   <a:srgbClr val="475569"/>
                 </a:solidFill>
@@ -17076,7 +16989,7 @@
         </p:nvSpPr>
         <p:spPr>
           <a:xfrm>
-            <a:off x="6720840" y="2788920"/>
+            <a:off x="6720840" y="2834640"/>
             <a:ext cx="4663440" cy="1005840"/>
           </a:xfrm>
           <a:prstGeom prst="rect">
@@ -17092,9 +17005,9 @@
           <a:p>
             <a:pPr algn="l">
               <a:lnSpc>
-                <a:spcPct val="110000"/>
-              </a:lnSpc>
-              <a:defRPr sz="1300" b="0" i="0">
+                <a:spcPct val="112000"/>
+              </a:lnSpc>
+              <a:defRPr sz="1400" b="0" i="0">
                 <a:solidFill>
                   <a:srgbClr val="475569"/>
                 </a:solidFill>
@@ -17131,9 +17044,9 @@
           <a:p>
             <a:pPr algn="l">
               <a:lnSpc>
-                <a:spcPct val="110000"/>
-              </a:lnSpc>
-              <a:defRPr sz="1300" b="0" i="0">
+                <a:spcPct val="112000"/>
+              </a:lnSpc>
+              <a:defRPr sz="1400" b="0" i="0">
                 <a:solidFill>
                   <a:srgbClr val="475569"/>
                 </a:solidFill>
@@ -17622,8 +17535,8 @@
         </p:nvSpPr>
         <p:spPr>
           <a:xfrm>
-            <a:off x="548640" y="2286000"/>
-            <a:ext cx="3108960" cy="3291840"/>
+            <a:off x="548640" y="1874519"/>
+            <a:ext cx="3108960" cy="3886200"/>
           </a:xfrm>
           <a:prstGeom prst="rect">
             <a:avLst/>
@@ -17631,16 +17544,16 @@
           <a:noFill/>
         </p:spPr>
         <p:txBody>
-          <a:bodyPr wrap="square" anchor="t">
+          <a:bodyPr wrap="square" anchor="ctr">
             <a:spAutoFit/>
           </a:bodyPr>
           <a:lstStyle/>
           <a:p>
             <a:pPr algn="l">
               <a:lnSpc>
-                <a:spcPct val="115000"/>
-              </a:lnSpc>
-              <a:defRPr sz="1400" b="0" i="0">
+                <a:spcPct val="120000"/>
+              </a:lnSpc>
+              <a:defRPr sz="1500" b="0" i="0">
                 <a:solidFill>
                   <a:srgbClr val="475569"/>
                 </a:solidFill>
@@ -17654,9 +17567,9 @@
           <a:p>
             <a:pPr algn="l">
               <a:lnSpc>
-                <a:spcPct val="115000"/>
-              </a:lnSpc>
-              <a:defRPr sz="1400" b="0" i="0">
+                <a:spcPct val="120000"/>
+              </a:lnSpc>
+              <a:defRPr sz="1500" b="0" i="0">
                 <a:solidFill>
                   <a:srgbClr val="475569"/>
                 </a:solidFill>
@@ -17670,9 +17583,9 @@
           <a:p>
             <a:pPr algn="l">
               <a:lnSpc>
-                <a:spcPct val="115000"/>
-              </a:lnSpc>
-              <a:defRPr sz="1400" b="0" i="0">
+                <a:spcPct val="120000"/>
+              </a:lnSpc>
+              <a:defRPr sz="1500" b="0" i="0">
                 <a:solidFill>
                   <a:srgbClr val="475569"/>
                 </a:solidFill>
@@ -17686,9 +17599,9 @@
           <a:p>
             <a:pPr algn="l">
               <a:lnSpc>
-                <a:spcPct val="115000"/>
-              </a:lnSpc>
-              <a:defRPr sz="1400" b="0" i="0">
+                <a:spcPct val="120000"/>
+              </a:lnSpc>
+              <a:defRPr sz="1500" b="0" i="0">
                 <a:solidFill>
                   <a:srgbClr val="475569"/>
                 </a:solidFill>
@@ -17702,9 +17615,9 @@
           <a:p>
             <a:pPr algn="l">
               <a:lnSpc>
-                <a:spcPct val="115000"/>
-              </a:lnSpc>
-              <a:defRPr sz="1400" b="0" i="0">
+                <a:spcPct val="120000"/>
+              </a:lnSpc>
+              <a:defRPr sz="1500" b="0" i="0">
                 <a:solidFill>
                   <a:srgbClr val="475569"/>
                 </a:solidFill>
@@ -17718,9 +17631,9 @@
           <a:p>
             <a:pPr algn="l">
               <a:lnSpc>
-                <a:spcPct val="115000"/>
-              </a:lnSpc>
-              <a:defRPr sz="1400" b="0" i="0">
+                <a:spcPct val="120000"/>
+              </a:lnSpc>
+              <a:defRPr sz="1500" b="0" i="0">
                 <a:solidFill>
                   <a:srgbClr val="475569"/>
                 </a:solidFill>
@@ -17734,9 +17647,9 @@
           <a:p>
             <a:pPr algn="l">
               <a:lnSpc>
-                <a:spcPct val="115000"/>
-              </a:lnSpc>
-              <a:defRPr sz="1400" b="0" i="0">
+                <a:spcPct val="120000"/>
+              </a:lnSpc>
+              <a:defRPr sz="1500" b="0" i="0">
                 <a:solidFill>
                   <a:srgbClr val="475569"/>
                 </a:solidFill>
@@ -17747,9 +17660,9 @@
           <a:p>
             <a:pPr algn="l">
               <a:lnSpc>
-                <a:spcPct val="115000"/>
-              </a:lnSpc>
-              <a:defRPr sz="1400" b="0" i="0">
+                <a:spcPct val="120000"/>
+              </a:lnSpc>
+              <a:defRPr sz="1500" b="0" i="0">
                 <a:solidFill>
                   <a:srgbClr val="475569"/>
                 </a:solidFill>
@@ -17763,9 +17676,9 @@
           <a:p>
             <a:pPr algn="l">
               <a:lnSpc>
-                <a:spcPct val="115000"/>
-              </a:lnSpc>
-              <a:defRPr sz="1400" b="0" i="0">
+                <a:spcPct val="120000"/>
+              </a:lnSpc>
+              <a:defRPr sz="1500" b="0" i="0">
                 <a:solidFill>
                   <a:srgbClr val="475569"/>
                 </a:solidFill>

</xml_diff>

<commit_message>
a0: drop 'mental model' terminology in favor of plain structure wording
The term drifted between two referents: the three-layer project structure
and the one rule (you write code + JSON, the CLI generates the rest).
Per user decision the term is removed entirely:
- en heading 'The mental model: three layers' -> 'Three layers, one direction'
- zh '三层心智模型' -> '三层结构，一个方向'
- deck agenda + ACT I divider + F2 slide kicker updated
- F2 figure kicker MENTAL MODEL -> STRUCTURE
</commit_message>
<xml_diff>
--- a/articles/decks/aws-agentcore-under-the-hood.pptx
+++ b/articles/decks/aws-agentcore-under-the-hood.pptx
@@ -10452,7 +10452,7 @@
               </a:defRPr>
             </a:pPr>
             <a:r>
-              <a:t>What AgentCore is, and the three-layer mental model</a:t>
+              <a:t>What AgentCore is, and the three layers you own</a:t>
             </a:r>
           </a:p>
         </p:txBody>
@@ -14507,7 +14507,7 @@
               </a:defRPr>
             </a:pPr>
             <a:r>
-              <a:t>The mental model</a:t>
+              <a:t>Three layers, one direction</a:t>
             </a:r>
           </a:p>
         </p:txBody>
@@ -14944,7 +14944,7 @@
         <p:spPr>
           <a:xfrm>
             <a:off x="548640" y="384048"/>
-            <a:ext cx="1581912" cy="310896"/>
+            <a:ext cx="1266444" cy="310896"/>
           </a:xfrm>
           <a:prstGeom prst="roundRect">
             <a:avLst>
@@ -14986,7 +14986,7 @@
               </a:defRPr>
             </a:pPr>
             <a:r>
-              <a:t>MENTAL MODEL</a:t>
+              <a:t>STRUCTURE</a:t>
             </a:r>
           </a:p>
         </p:txBody>

</xml_diff>

<commit_message>
a0 rebalance: shift budget from narrative to the thin steps
User asked whether the article is too long; analysis showed ~46% was
reading-only narrative while Step 2 (contract) and Step 4 (local run)
were too thin to follow. Rebalanced:
- narrative (intro, positioning, under-the-hood, failures, takeaways)
  compressed ~20%; setup section tightened
- Step 2 +~130 words: the four must-get-right fields, project vs runtime
  naming, and a real 'agentcore validate' pass (output captured live)
- Step 4 +~90 words: dev -l vs browser UI, what to look for in the SSE
  stream, -p/-b/--skip-deploy flags, hot-reload loop
- deck synced: contract panel shows 'agentcore validate -> Valid',
  local slide shows 'agentcore dev -l' and the flag list
Result: en 2,215 -> 2,144 words (Flesch 65.5, final_check clean);
zh prose ~flat with the same two additions. Further cuts to ~1,950
would require dropping substance (cost paragraph, setup section,
three-layers section) - left for user decision.
</commit_message>
<xml_diff>
--- a/articles/decks/aws-agentcore-under-the-hood.pptx
+++ b/articles/decks/aws-agentcore-under-the-hood.pptx
@@ -3860,13 +3860,13 @@
               </a:lnSpc>
               <a:defRPr sz="1400">
                 <a:solidFill>
-                  <a:srgbClr val="94A3B8"/>
+                  <a:srgbClr val="E2E8F0"/>
                 </a:solidFill>
                 <a:latin typeface="Menlo"/>
               </a:defRPr>
             </a:pPr>
             <a:r>
-              <a:t>  ...15 arrays, all empty...</a:t>
+              <a:t>}</a:t>
             </a:r>
           </a:p>
           <a:p>
@@ -3876,13 +3876,13 @@
               </a:lnSpc>
               <a:defRPr sz="1400">
                 <a:solidFill>
-                  <a:srgbClr val="E2E8F0"/>
+                  <a:srgbClr val="34D399"/>
                 </a:solidFill>
                 <a:latin typeface="Menlo"/>
               </a:defRPr>
             </a:pPr>
             <a:r>
-              <a:t>}</a:t>
+              <a:t>$ agentcore validate   # -&gt; Valid</a:t>
             </a:r>
           </a:p>
         </p:txBody>
@@ -6427,7 +6427,7 @@
               </a:defRPr>
             </a:pPr>
             <a:r>
-              <a:t>$ agentcore dev</a:t>
+              <a:t>$ agentcore dev -l</a:t>
             </a:r>
           </a:p>
           <a:p>
@@ -6579,9 +6579,9 @@
           <a:p>
             <a:pPr algn="l">
               <a:lnSpc>
-                <a:spcPct val="125000"/>
-              </a:lnSpc>
-              <a:defRPr sz="1600" b="0" i="0">
+                <a:spcPct val="120000"/>
+              </a:lnSpc>
+              <a:defRPr sz="1500" b="0" i="0">
                 <a:solidFill>
                   <a:srgbClr val="475569"/>
                 </a:solidFill>
@@ -6595,9 +6595,9 @@
           <a:p>
             <a:pPr algn="l">
               <a:lnSpc>
-                <a:spcPct val="125000"/>
-              </a:lnSpc>
-              <a:defRPr sz="1600" b="0" i="0">
+                <a:spcPct val="120000"/>
+              </a:lnSpc>
+              <a:defRPr sz="1500" b="0" i="0">
                 <a:solidFill>
                   <a:srgbClr val="475569"/>
                 </a:solidFill>
@@ -6611,9 +6611,9 @@
           <a:p>
             <a:pPr algn="l">
               <a:lnSpc>
-                <a:spcPct val="125000"/>
-              </a:lnSpc>
-              <a:defRPr sz="1600" b="0" i="0">
+                <a:spcPct val="120000"/>
+              </a:lnSpc>
+              <a:defRPr sz="1500" b="0" i="0">
                 <a:solidFill>
                   <a:srgbClr val="475569"/>
                 </a:solidFill>
@@ -6627,9 +6627,9 @@
           <a:p>
             <a:pPr algn="l">
               <a:lnSpc>
-                <a:spcPct val="125000"/>
-              </a:lnSpc>
-              <a:defRPr sz="1600" b="0" i="0">
+                <a:spcPct val="120000"/>
+              </a:lnSpc>
+              <a:defRPr sz="1500" b="0" i="0">
                 <a:solidFill>
                   <a:srgbClr val="475569"/>
                 </a:solidFill>
@@ -6640,9 +6640,9 @@
           <a:p>
             <a:pPr algn="l">
               <a:lnSpc>
-                <a:spcPct val="125000"/>
-              </a:lnSpc>
-              <a:defRPr sz="1600" b="0" i="0">
+                <a:spcPct val="120000"/>
+              </a:lnSpc>
+              <a:defRPr sz="1500" b="0" i="0">
                 <a:solidFill>
                   <a:srgbClr val="475569"/>
                 </a:solidFill>
@@ -6650,15 +6650,60 @@
               </a:defRPr>
             </a:pPr>
             <a:r>
+              <a:t>Flags worth knowing:</a:t>
+            </a:r>
+          </a:p>
+          <a:p>
+            <a:pPr algn="l">
+              <a:lnSpc>
+                <a:spcPct val="120000"/>
+              </a:lnSpc>
+              <a:defRPr sz="1500" b="0" i="0">
+                <a:solidFill>
+                  <a:srgbClr val="475569"/>
+                </a:solidFill>
+                <a:latin typeface="Helvetica Neue"/>
+              </a:defRPr>
+            </a:pPr>
+            <a:r>
+              <a:t>-p port, -b TUI, --skip-deploy.</a:t>
+            </a:r>
+          </a:p>
+          <a:p>
+            <a:pPr algn="l">
+              <a:lnSpc>
+                <a:spcPct val="120000"/>
+              </a:lnSpc>
+              <a:defRPr sz="1500" b="0" i="0">
+                <a:solidFill>
+                  <a:srgbClr val="475569"/>
+                </a:solidFill>
+                <a:latin typeface="Helvetica Neue"/>
+              </a:defRPr>
+            </a:pPr>
+          </a:p>
+          <a:p>
+            <a:pPr algn="l">
+              <a:lnSpc>
+                <a:spcPct val="120000"/>
+              </a:lnSpc>
+              <a:defRPr sz="1500" b="0" i="0">
+                <a:solidFill>
+                  <a:srgbClr val="475569"/>
+                </a:solidFill>
+                <a:latin typeface="Helvetica Neue"/>
+              </a:defRPr>
+            </a:pPr>
+            <a:r>
               <a:t>Edit main.py while it runs:</a:t>
             </a:r>
           </a:p>
           <a:p>
             <a:pPr algn="l">
               <a:lnSpc>
-                <a:spcPct val="125000"/>
-              </a:lnSpc>
-              <a:defRPr sz="1600" b="0" i="0">
+                <a:spcPct val="120000"/>
+              </a:lnSpc>
+              <a:defRPr sz="1500" b="0" i="0">
                 <a:solidFill>
                   <a:srgbClr val="475569"/>
                 </a:solidFill>
@@ -6672,9 +6717,9 @@
           <a:p>
             <a:pPr algn="l">
               <a:lnSpc>
-                <a:spcPct val="125000"/>
-              </a:lnSpc>
-              <a:defRPr sz="1600" b="0" i="0">
+                <a:spcPct val="120000"/>
+              </a:lnSpc>
+              <a:defRPr sz="1500" b="0" i="0">
                 <a:solidFill>
                   <a:srgbClr val="475569"/>
                 </a:solidFill>

</xml_diff>

<commit_message>
a0: redraw F3 to match real 'agentcore create' output
The old F3 showed the finished UC01 layout (src/, tests/) plus two
entries that do not exist (.cache/) and missed real ones (AGENTS.md,
root README.md, .env.local, .llm-context contents, .cli). Re-captured
the real trees by running create twice:

- create --no-agent --build CodeZip -> project root with AGENTS.md,
  README.md, agentcore/{agentcore.json, aws-targets.json, .env.local,
  .llm-context/, .cli/, cdk/}; no code folder; full [done] output
  captured (3 steps + Created block) and now quoted in the article
- create with --framework Strands --model-provider Bedrock --memory
  none -> additionally app/<name>/ with the starter agent

F3 is now two panels: CREATE WRITES IT (real generated tree, the two
contract files flagged 'you edit') and YOU ADD IT (src/ + tests/, with
the app/-vs-src note). Article prose in both languages updated to the
real output and the no-code-folder fact; deck side text synced.
</commit_message>
<xml_diff>
--- a/articles/decks/aws-agentcore-under-the-hood.pptx
+++ b/articles/decks/aws-agentcore-under-the-hood.pptx
@@ -17565,7 +17565,7 @@
         <p:spPr>
           <a:xfrm>
             <a:off x="3794760" y="1874519"/>
-            <a:ext cx="5120640" cy="4430776"/>
+            <a:ext cx="5120640" cy="4370324"/>
           </a:xfrm>
           <a:prstGeom prst="rect">
             <a:avLst/>
@@ -17606,7 +17606,7 @@
               </a:defRPr>
             </a:pPr>
             <a:r>
-              <a:t>create writes</a:t>
+              <a:t>create writes the whole</a:t>
             </a:r>
           </a:p>
           <a:p>
@@ -17622,7 +17622,7 @@
               </a:defRPr>
             </a:pPr>
             <a:r>
-              <a:t>agentcore.json</a:t>
+              <a:t>agentcore/ tree - but only</a:t>
             </a:r>
           </a:p>
           <a:p>
@@ -17638,7 +17638,7 @@
               </a:defRPr>
             </a:pPr>
             <a:r>
-              <a:t>with 15 empty</a:t>
+              <a:t>two files are yours to edit:</a:t>
             </a:r>
           </a:p>
           <a:p>
@@ -17654,7 +17654,7 @@
               </a:defRPr>
             </a:pPr>
             <a:r>
-              <a:t>resource arrays,</a:t>
+              <a:t>agentcore.json and</a:t>
             </a:r>
           </a:p>
           <a:p>
@@ -17670,7 +17670,7 @@
               </a:defRPr>
             </a:pPr>
             <a:r>
-              <a:t>and aws-targets.json</a:t>
+              <a:t>aws-targets.json.</a:t>
             </a:r>
           </a:p>
           <a:p>
@@ -17685,9 +17685,6 @@
                 <a:latin typeface="Helvetica Neue"/>
               </a:defRPr>
             </a:pPr>
-            <a:r>
-              <a:t>with just [ ]</a:t>
-            </a:r>
           </a:p>
           <a:p>
             <a:pPr algn="l">
@@ -17701,6 +17698,9 @@
                 <a:latin typeface="Helvetica Neue"/>
               </a:defRPr>
             </a:pPr>
+            <a:r>
+              <a:t>Everything else is</a:t>
+            </a:r>
           </a:p>
           <a:p>
             <a:pPr algn="l">
@@ -17715,7 +17715,7 @@
               </a:defRPr>
             </a:pPr>
             <a:r>
-              <a:t>Blue = you write</a:t>
+              <a:t>regenerable. --no-agent</a:t>
             </a:r>
           </a:p>
           <a:p>
@@ -17731,7 +17731,7 @@
               </a:defRPr>
             </a:pPr>
             <a:r>
-              <a:t>Gray = CLI generates</a:t>
+              <a:t>ships no code folder.</a:t>
             </a:r>
           </a:p>
         </p:txBody>

</xml_diff>

<commit_message>
a0: align environment + scaffold with the official getting-started sample
The official awslabs/agentcore-samples 00-getting-started README uses
agentcore create --name CustomerSupport --framework Strands
--model-provider Bedrock --memory none --defaults and documents the
generated tree (app/<AgentName>/ with main.py, model/load.py,
mcp_client/, pyproject.toml).

- env table gains uv (CLI builds the template agent's Python env with
  it) and Git (create runs git init); check block extended accordingly,
  'four checks' wording de-counted; dates updated to 10-14/15
- Step 1 now cites the official full-form command and notes the two
  extra steps ('Add agent to project', 'Set up Python environment')
  that appear when an agent is scaffolded
- deck env slide lists uv + Git too
</commit_message>
<xml_diff>
--- a/articles/decks/aws-agentcore-under-the-hood.pptx
+++ b/articles/decks/aws-agentcore-under-the-hood.pptx
@@ -16433,7 +16433,7 @@
         </p:nvSpPr>
         <p:spPr>
           <a:xfrm>
-            <a:off x="868680" y="2788920"/>
+            <a:off x="868680" y="2743200"/>
             <a:ext cx="1920240" cy="365760"/>
           </a:xfrm>
           <a:prstGeom prst="rect">
@@ -16451,7 +16451,7 @@
               <a:lnSpc>
                 <a:spcPct val="100000"/>
               </a:lnSpc>
-              <a:defRPr sz="1400" b="1" i="0">
+              <a:defRPr sz="1350" b="1" i="0">
                 <a:solidFill>
                   <a:srgbClr val="0F172A"/>
                 </a:solidFill>
@@ -16472,7 +16472,7 @@
         </p:nvSpPr>
         <p:spPr>
           <a:xfrm>
-            <a:off x="2834640" y="2788920"/>
+            <a:off x="2834640" y="2743200"/>
             <a:ext cx="3200400" cy="365760"/>
           </a:xfrm>
           <a:prstGeom prst="rect">
@@ -16490,7 +16490,7 @@
               <a:lnSpc>
                 <a:spcPct val="100000"/>
               </a:lnSpc>
-              <a:defRPr sz="1400" b="0" i="0">
+              <a:defRPr sz="1350" b="0" i="0">
                 <a:solidFill>
                   <a:srgbClr val="475569"/>
                 </a:solidFill>
@@ -16511,7 +16511,7 @@
         </p:nvSpPr>
         <p:spPr>
           <a:xfrm>
-            <a:off x="868680" y="3282696"/>
+            <a:off x="868680" y="3127248"/>
             <a:ext cx="1920240" cy="365760"/>
           </a:xfrm>
           <a:prstGeom prst="rect">
@@ -16529,7 +16529,7 @@
               <a:lnSpc>
                 <a:spcPct val="100000"/>
               </a:lnSpc>
-              <a:defRPr sz="1400" b="1" i="0">
+              <a:defRPr sz="1350" b="1" i="0">
                 <a:solidFill>
                   <a:srgbClr val="0F172A"/>
                 </a:solidFill>
@@ -16550,7 +16550,7 @@
         </p:nvSpPr>
         <p:spPr>
           <a:xfrm>
-            <a:off x="2834640" y="3282696"/>
+            <a:off x="2834640" y="3127248"/>
             <a:ext cx="3200400" cy="365760"/>
           </a:xfrm>
           <a:prstGeom prst="rect">
@@ -16568,7 +16568,7 @@
               <a:lnSpc>
                 <a:spcPct val="100000"/>
               </a:lnSpc>
-              <a:defRPr sz="1400" b="0" i="0">
+              <a:defRPr sz="1350" b="0" i="0">
                 <a:solidFill>
                   <a:srgbClr val="475569"/>
                 </a:solidFill>
@@ -16589,7 +16589,7 @@
         </p:nvSpPr>
         <p:spPr>
           <a:xfrm>
-            <a:off x="868680" y="3776472"/>
+            <a:off x="868680" y="3511296"/>
             <a:ext cx="1920240" cy="365760"/>
           </a:xfrm>
           <a:prstGeom prst="rect">
@@ -16607,7 +16607,7 @@
               <a:lnSpc>
                 <a:spcPct val="100000"/>
               </a:lnSpc>
-              <a:defRPr sz="1400" b="1" i="0">
+              <a:defRPr sz="1350" b="1" i="0">
                 <a:solidFill>
                   <a:srgbClr val="0F172A"/>
                 </a:solidFill>
@@ -16628,7 +16628,7 @@
         </p:nvSpPr>
         <p:spPr>
           <a:xfrm>
-            <a:off x="2834640" y="3776472"/>
+            <a:off x="2834640" y="3511296"/>
             <a:ext cx="3200400" cy="365760"/>
           </a:xfrm>
           <a:prstGeom prst="rect">
@@ -16646,7 +16646,7 @@
               <a:lnSpc>
                 <a:spcPct val="100000"/>
               </a:lnSpc>
-              <a:defRPr sz="1400" b="0" i="0">
+              <a:defRPr sz="1350" b="0" i="0">
                 <a:solidFill>
                   <a:srgbClr val="475569"/>
                 </a:solidFill>
@@ -16667,7 +16667,7 @@
         </p:nvSpPr>
         <p:spPr>
           <a:xfrm>
-            <a:off x="868680" y="4270248"/>
+            <a:off x="868680" y="3895344"/>
             <a:ext cx="1920240" cy="365760"/>
           </a:xfrm>
           <a:prstGeom prst="rect">
@@ -16685,7 +16685,7 @@
               <a:lnSpc>
                 <a:spcPct val="100000"/>
               </a:lnSpc>
-              <a:defRPr sz="1400" b="1" i="0">
+              <a:defRPr sz="1350" b="1" i="0">
                 <a:solidFill>
                   <a:srgbClr val="0F172A"/>
                 </a:solidFill>
@@ -16693,7 +16693,7 @@
               </a:defRPr>
             </a:pPr>
             <a:r>
-              <a:t>Python</a:t>
+              <a:t>uv</a:t>
             </a:r>
           </a:p>
         </p:txBody>
@@ -16706,7 +16706,7 @@
         </p:nvSpPr>
         <p:spPr>
           <a:xfrm>
-            <a:off x="2834640" y="4270248"/>
+            <a:off x="2834640" y="3895344"/>
             <a:ext cx="3200400" cy="365760"/>
           </a:xfrm>
           <a:prstGeom prst="rect">
@@ -16724,7 +16724,7 @@
               <a:lnSpc>
                 <a:spcPct val="100000"/>
               </a:lnSpc>
-              <a:defRPr sz="1400" b="0" i="0">
+              <a:defRPr sz="1350" b="0" i="0">
                 <a:solidFill>
                   <a:srgbClr val="475569"/>
                 </a:solidFill>
@@ -16732,7 +16732,7 @@
               </a:defRPr>
             </a:pPr>
             <a:r>
-              <a:t>3.11 local · CodeZip allows 3.10-3.13</a:t>
+              <a:t>0.11.9 (template agents)</a:t>
             </a:r>
           </a:p>
         </p:txBody>
@@ -16745,7 +16745,7 @@
         </p:nvSpPr>
         <p:spPr>
           <a:xfrm>
-            <a:off x="868680" y="4764024"/>
+            <a:off x="868680" y="4279392"/>
             <a:ext cx="1920240" cy="365760"/>
           </a:xfrm>
           <a:prstGeom prst="rect">
@@ -16763,7 +16763,7 @@
               <a:lnSpc>
                 <a:spcPct val="100000"/>
               </a:lnSpc>
-              <a:defRPr sz="1400" b="1" i="0">
+              <a:defRPr sz="1350" b="1" i="0">
                 <a:solidFill>
                   <a:srgbClr val="0F172A"/>
                 </a:solidFill>
@@ -16771,7 +16771,7 @@
               </a:defRPr>
             </a:pPr>
             <a:r>
-              <a:t>Region</a:t>
+              <a:t>Git</a:t>
             </a:r>
           </a:p>
         </p:txBody>
@@ -16784,7 +16784,7 @@
         </p:nvSpPr>
         <p:spPr>
           <a:xfrm>
-            <a:off x="2834640" y="4764024"/>
+            <a:off x="2834640" y="4279392"/>
             <a:ext cx="3200400" cy="365760"/>
           </a:xfrm>
           <a:prstGeom prst="rect">
@@ -16802,7 +16802,7 @@
               <a:lnSpc>
                 <a:spcPct val="100000"/>
               </a:lnSpc>
-              <a:defRPr sz="1400" b="0" i="0">
+              <a:defRPr sz="1350" b="0" i="0">
                 <a:solidFill>
                   <a:srgbClr val="475569"/>
                 </a:solidFill>
@@ -16810,7 +16810,7 @@
               </a:defRPr>
             </a:pPr>
             <a:r>
-              <a:t>us-east-1 (whole series)</a:t>
+              <a:t>2.39 (create runs git init)</a:t>
             </a:r>
           </a:p>
         </p:txBody>
@@ -16823,7 +16823,7 @@
         </p:nvSpPr>
         <p:spPr>
           <a:xfrm>
-            <a:off x="868680" y="5257800"/>
+            <a:off x="868680" y="4663440"/>
             <a:ext cx="1920240" cy="365760"/>
           </a:xfrm>
           <a:prstGeom prst="rect">
@@ -16841,7 +16841,7 @@
               <a:lnSpc>
                 <a:spcPct val="100000"/>
               </a:lnSpc>
-              <a:defRPr sz="1400" b="1" i="0">
+              <a:defRPr sz="1350" b="1" i="0">
                 <a:solidFill>
                   <a:srgbClr val="0F172A"/>
                 </a:solidFill>
@@ -16849,7 +16849,7 @@
               </a:defRPr>
             </a:pPr>
             <a:r>
-              <a:t>Docker</a:t>
+              <a:t>Python</a:t>
             </a:r>
           </a:p>
         </p:txBody>
@@ -16862,7 +16862,7 @@
         </p:nvSpPr>
         <p:spPr>
           <a:xfrm>
-            <a:off x="2834640" y="5257800"/>
+            <a:off x="2834640" y="4663440"/>
             <a:ext cx="3200400" cy="365760"/>
           </a:xfrm>
           <a:prstGeom prst="rect">
@@ -16880,7 +16880,7 @@
               <a:lnSpc>
                 <a:spcPct val="100000"/>
               </a:lnSpc>
-              <a:defRPr sz="1400" b="0" i="0">
+              <a:defRPr sz="1350" b="0" i="0">
                 <a:solidFill>
                   <a:srgbClr val="475569"/>
                 </a:solidFill>
@@ -16888,6 +16888,162 @@
               </a:defRPr>
             </a:pPr>
             <a:r>
+              <a:t>3.11 local, CodeZip allows 3.10-3.13</a:t>
+            </a:r>
+          </a:p>
+        </p:txBody>
+      </p:sp>
+      <p:sp>
+        <p:nvSpPr>
+          <p:cNvPr id="20" name="TextBox 19"/>
+          <p:cNvSpPr txBox="1"/>
+          <p:nvPr/>
+        </p:nvSpPr>
+        <p:spPr>
+          <a:xfrm>
+            <a:off x="868680" y="5047488"/>
+            <a:ext cx="1920240" cy="365760"/>
+          </a:xfrm>
+          <a:prstGeom prst="rect">
+            <a:avLst/>
+          </a:prstGeom>
+          <a:noFill/>
+        </p:spPr>
+        <p:txBody>
+          <a:bodyPr wrap="square" anchor="t">
+            <a:spAutoFit/>
+          </a:bodyPr>
+          <a:lstStyle/>
+          <a:p>
+            <a:pPr algn="l">
+              <a:lnSpc>
+                <a:spcPct val="100000"/>
+              </a:lnSpc>
+              <a:defRPr sz="1350" b="1" i="0">
+                <a:solidFill>
+                  <a:srgbClr val="0F172A"/>
+                </a:solidFill>
+                <a:latin typeface="Helvetica Neue"/>
+              </a:defRPr>
+            </a:pPr>
+            <a:r>
+              <a:t>Region</a:t>
+            </a:r>
+          </a:p>
+        </p:txBody>
+      </p:sp>
+      <p:sp>
+        <p:nvSpPr>
+          <p:cNvPr id="21" name="TextBox 20"/>
+          <p:cNvSpPr txBox="1"/>
+          <p:nvPr/>
+        </p:nvSpPr>
+        <p:spPr>
+          <a:xfrm>
+            <a:off x="2834640" y="5047488"/>
+            <a:ext cx="3200400" cy="365760"/>
+          </a:xfrm>
+          <a:prstGeom prst="rect">
+            <a:avLst/>
+          </a:prstGeom>
+          <a:noFill/>
+        </p:spPr>
+        <p:txBody>
+          <a:bodyPr wrap="square" anchor="t">
+            <a:spAutoFit/>
+          </a:bodyPr>
+          <a:lstStyle/>
+          <a:p>
+            <a:pPr algn="l">
+              <a:lnSpc>
+                <a:spcPct val="100000"/>
+              </a:lnSpc>
+              <a:defRPr sz="1350" b="0" i="0">
+                <a:solidFill>
+                  <a:srgbClr val="475569"/>
+                </a:solidFill>
+                <a:latin typeface="Helvetica Neue"/>
+              </a:defRPr>
+            </a:pPr>
+            <a:r>
+              <a:t>us-east-1 (whole series)</a:t>
+            </a:r>
+          </a:p>
+        </p:txBody>
+      </p:sp>
+      <p:sp>
+        <p:nvSpPr>
+          <p:cNvPr id="22" name="TextBox 21"/>
+          <p:cNvSpPr txBox="1"/>
+          <p:nvPr/>
+        </p:nvSpPr>
+        <p:spPr>
+          <a:xfrm>
+            <a:off x="868680" y="5431536"/>
+            <a:ext cx="1920240" cy="365760"/>
+          </a:xfrm>
+          <a:prstGeom prst="rect">
+            <a:avLst/>
+          </a:prstGeom>
+          <a:noFill/>
+        </p:spPr>
+        <p:txBody>
+          <a:bodyPr wrap="square" anchor="t">
+            <a:spAutoFit/>
+          </a:bodyPr>
+          <a:lstStyle/>
+          <a:p>
+            <a:pPr algn="l">
+              <a:lnSpc>
+                <a:spcPct val="100000"/>
+              </a:lnSpc>
+              <a:defRPr sz="1350" b="1" i="0">
+                <a:solidFill>
+                  <a:srgbClr val="0F172A"/>
+                </a:solidFill>
+                <a:latin typeface="Helvetica Neue"/>
+              </a:defRPr>
+            </a:pPr>
+            <a:r>
+              <a:t>Docker</a:t>
+            </a:r>
+          </a:p>
+        </p:txBody>
+      </p:sp>
+      <p:sp>
+        <p:nvSpPr>
+          <p:cNvPr id="23" name="TextBox 22"/>
+          <p:cNvSpPr txBox="1"/>
+          <p:nvPr/>
+        </p:nvSpPr>
+        <p:spPr>
+          <a:xfrm>
+            <a:off x="2834640" y="5431536"/>
+            <a:ext cx="3200400" cy="365760"/>
+          </a:xfrm>
+          <a:prstGeom prst="rect">
+            <a:avLst/>
+          </a:prstGeom>
+          <a:noFill/>
+        </p:spPr>
+        <p:txBody>
+          <a:bodyPr wrap="square" anchor="t">
+            <a:spAutoFit/>
+          </a:bodyPr>
+          <a:lstStyle/>
+          <a:p>
+            <a:pPr algn="l">
+              <a:lnSpc>
+                <a:spcPct val="100000"/>
+              </a:lnSpc>
+              <a:defRPr sz="1350" b="0" i="0">
+                <a:solidFill>
+                  <a:srgbClr val="475569"/>
+                </a:solidFill>
+                <a:latin typeface="Helvetica Neue"/>
+              </a:defRPr>
+            </a:pPr>
+            <a:r>
               <a:t>not needed - CodeZip builds</a:t>
             </a:r>
           </a:p>
@@ -16895,7 +17051,7 @@
       </p:sp>
       <p:sp>
         <p:nvSpPr>
-          <p:cNvPr id="20" name="Rounded Rectangle 19"/>
+          <p:cNvPr id="24" name="Rounded Rectangle 23"/>
           <p:cNvSpPr/>
           <p:nvPr/>
         </p:nvSpPr>
@@ -16943,7 +17099,7 @@
       </p:sp>
       <p:sp>
         <p:nvSpPr>
-          <p:cNvPr id="21" name="Rounded Rectangle 20"/>
+          <p:cNvPr id="25" name="Rounded Rectangle 24"/>
           <p:cNvSpPr/>
           <p:nvPr/>
         </p:nvSpPr>
@@ -16989,7 +17145,7 @@
       </p:sp>
       <p:sp>
         <p:nvSpPr>
-          <p:cNvPr id="22" name="TextBox 21"/>
+          <p:cNvPr id="26" name="TextBox 25"/>
           <p:cNvSpPr txBox="1"/>
           <p:nvPr/>
         </p:nvSpPr>
@@ -17028,7 +17184,7 @@
       </p:sp>
       <p:sp>
         <p:nvSpPr>
-          <p:cNvPr id="23" name="TextBox 22"/>
+          <p:cNvPr id="27" name="TextBox 26"/>
           <p:cNvSpPr txBox="1"/>
           <p:nvPr/>
         </p:nvSpPr>
@@ -17067,7 +17223,7 @@
       </p:sp>
       <p:sp>
         <p:nvSpPr>
-          <p:cNvPr id="24" name="TextBox 23"/>
+          <p:cNvPr id="28" name="TextBox 27"/>
           <p:cNvSpPr txBox="1"/>
           <p:nvPr/>
         </p:nvSpPr>
@@ -17106,7 +17262,7 @@
       </p:sp>
       <p:sp>
         <p:nvSpPr>
-          <p:cNvPr id="25" name="Rounded Rectangle 24"/>
+          <p:cNvPr id="29" name="Rounded Rectangle 28"/>
           <p:cNvSpPr/>
           <p:nvPr/>
         </p:nvSpPr>
@@ -17154,7 +17310,7 @@
       </p:sp>
       <p:sp>
         <p:nvSpPr>
-          <p:cNvPr id="26" name="TextBox 25"/>
+          <p:cNvPr id="30" name="TextBox 29"/>
           <p:cNvSpPr txBox="1"/>
           <p:nvPr/>
         </p:nvSpPr>
@@ -17193,7 +17349,7 @@
       </p:sp>
       <p:sp>
         <p:nvSpPr>
-          <p:cNvPr id="27" name="Rectangle 26"/>
+          <p:cNvPr id="31" name="Rectangle 30"/>
           <p:cNvSpPr/>
           <p:nvPr/>
         </p:nvSpPr>
@@ -17237,7 +17393,7 @@
       </p:sp>
       <p:sp>
         <p:nvSpPr>
-          <p:cNvPr id="28" name="TextBox 27"/>
+          <p:cNvPr id="32" name="TextBox 31"/>
           <p:cNvSpPr txBox="1"/>
           <p:nvPr/>
         </p:nvSpPr>
@@ -17276,7 +17432,7 @@
       </p:sp>
       <p:sp>
         <p:nvSpPr>
-          <p:cNvPr id="29" name="TextBox 28"/>
+          <p:cNvPr id="33" name="TextBox 32"/>
           <p:cNvSpPr txBox="1"/>
           <p:nvPr/>
         </p:nvSpPr>

</xml_diff>